<commit_message>
Add speaker notes to optimization presentation
</commit_message>
<xml_diff>
--- a/deliverables/GPGPU算子自动优化工作成果.pptx
+++ b/deliverables/GPGPU算子自动优化工作成果.pptx
@@ -2,18 +2,18 @@
 <file path=ppt/presentation.xml><?xml version="1.0" encoding="utf-8"?>
 <p:presentation xmlns:p="http://schemas.openxmlformats.org/presentationml/2006/main">
   <p:sldMasterIdLst>
-    <p:sldMasterId xmlns:r="http://schemas.openxmlformats.org/officeDocument/2006/relationships" id="2147483648" r:id="R2563c7b414ae4b89"/>
+    <p:sldMasterId xmlns:r="http://schemas.openxmlformats.org/officeDocument/2006/relationships" id="2147483648" r:id="R226688decdd84e77"/>
   </p:sldMasterIdLst>
   <p:notesMasterIdLst>
-    <p:notesMasterId xmlns:r="http://schemas.openxmlformats.org/officeDocument/2006/relationships" r:id="Rc85a1f2f70b54cd0"/>
+    <p:notesMasterId xmlns:r="http://schemas.openxmlformats.org/officeDocument/2006/relationships" r:id="Rca00c06dce0246b7"/>
   </p:notesMasterIdLst>
   <p:sldIdLst>
-    <p:sldId xmlns:r="http://schemas.openxmlformats.org/officeDocument/2006/relationships" id="256" r:id="R9763c090a0b14bf4"/>
-    <p:sldId xmlns:r="http://schemas.openxmlformats.org/officeDocument/2006/relationships" id="257" r:id="Rbeb7b5bd851042d3"/>
-    <p:sldId xmlns:r="http://schemas.openxmlformats.org/officeDocument/2006/relationships" id="258" r:id="R1c4ab5bf34e5461a"/>
-    <p:sldId xmlns:r="http://schemas.openxmlformats.org/officeDocument/2006/relationships" id="259" r:id="R90a3d92da2f74ec6"/>
-    <p:sldId xmlns:r="http://schemas.openxmlformats.org/officeDocument/2006/relationships" id="260" r:id="Rcca2a6d48e35483e"/>
-    <p:sldId xmlns:r="http://schemas.openxmlformats.org/officeDocument/2006/relationships" id="261" r:id="R3c5a9be64b4c4c1e"/>
+    <p:sldId xmlns:r="http://schemas.openxmlformats.org/officeDocument/2006/relationships" id="256" r:id="R4ff2fb44dc374d5a"/>
+    <p:sldId xmlns:r="http://schemas.openxmlformats.org/officeDocument/2006/relationships" id="257" r:id="Rdffa6e7114554060"/>
+    <p:sldId xmlns:r="http://schemas.openxmlformats.org/officeDocument/2006/relationships" id="258" r:id="Rd0dec91ee5a845ed"/>
+    <p:sldId xmlns:r="http://schemas.openxmlformats.org/officeDocument/2006/relationships" id="259" r:id="R08057e3674274704"/>
+    <p:sldId xmlns:r="http://schemas.openxmlformats.org/officeDocument/2006/relationships" id="260" r:id="Rf05cc09f28924e38"/>
+    <p:sldId xmlns:r="http://schemas.openxmlformats.org/officeDocument/2006/relationships" id="261" r:id="Rb343e040f1b14f51"/>
   </p:sldIdLst>
   <p:sldSz cx="12192000" cy="6858000"/>
   <p:notesSz cx="6858000" cy="9144000"/>
@@ -447,7 +447,27 @@
           <a:lstStyle xmlns:a="http://schemas.openxmlformats.org/drawingml/2006/main"/>
           <a:p xmlns:a="http://schemas.openxmlformats.org/drawingml/2006/main">
             <a:r>
-              <a:t>数据来源：项目 README.md 与 experiments/kda_repro/AGENT_ORDINARY_BASELINE_V100_RESULT.md。测试设备为 Tesla V100-PCIE-32GB。</a:t>
+              <a:t>这一页先简单介绍我们的工作。我们关注的是 GPU 算子自动优化，也就是让 Agent 帮我们分析算子、选择优化方案，再由系统自动编译和测试。当前主要在 V100 上复现 KDA 的思路。最直观的结果是，GDN Decode 从普通 PyTorch 实现优化到 Triton 后，实测加速接近 11 倍。</a:t>
+            </a:r>
+          </a:p>
+          <a:p xmlns:a="http://schemas.openxmlformats.org/drawingml/2006/main">
+            <a:r>
+              <a:t/>
+            </a:r>
+          </a:p>
+          <a:p xmlns:a="http://schemas.openxmlformats.org/drawingml/2006/main">
+            <a:r>
+              <a:t>这一页不用展开技术细节，先让大家知道我们做的是一套完整流程，不只是手工改了一个算子。</a:t>
+            </a:r>
+          </a:p>
+          <a:p xmlns:a="http://schemas.openxmlformats.org/drawingml/2006/main">
+            <a:r>
+              <a:t/>
+            </a:r>
+          </a:p>
+          <a:p xmlns:a="http://schemas.openxmlformats.org/drawingml/2006/main">
+            <a:r>
+              <a:t>资料来源：项目 README.md；AGENT_ORDINARY_BASELINE_V100_RESULT.md。</a:t>
             </a:r>
           </a:p>
         </p:txBody>
@@ -517,7 +537,27 @@
           <a:lstStyle xmlns:a="http://schemas.openxmlformats.org/drawingml/2006/main"/>
           <a:p xmlns:a="http://schemas.openxmlformats.org/drawingml/2006/main">
             <a:r>
-              <a:t>来源：README.md；GDN Decode 10.985×实验；GDN Prefill Agent 结果；V100 RMSNorm 严格结果。RMSNorm 数字为 CUDA Graph 微基准，不代表端到端训练加速。</a:t>
+              <a:t>这里汇总目前最主要的成果。GDN Decode 从普通 PyTorch 基线出发，流程内加速是 10.985 倍。Decode 的 54 组官方输入和 Prefill 的 100 组官方输入都已经全部验证正确。Residual Add RMSNorm 相对未融合的 PyTorch 表达式，也有 5.60 到 10.13 倍的提升。</a:t>
+            </a:r>
+          </a:p>
+          <a:p xmlns:a="http://schemas.openxmlformats.org/drawingml/2006/main">
+            <a:r>
+              <a:t/>
+            </a:r>
+          </a:p>
+          <a:p xmlns:a="http://schemas.openxmlformats.org/drawingml/2006/main">
+            <a:r>
+              <a:t>需要注意，这几组数字的基线不同。10.985 倍和 RMSNorm 的几倍提升，都是相对普通或未融合 PyTorch。后面还会单独说明，相对已经优化得比较好的 Triton 基线，提升会小很多。</a:t>
+            </a:r>
+          </a:p>
+          <a:p xmlns:a="http://schemas.openxmlformats.org/drawingml/2006/main">
+            <a:r>
+              <a:t/>
+            </a:r>
+          </a:p>
+          <a:p xmlns:a="http://schemas.openxmlformats.org/drawingml/2006/main">
+            <a:r>
+              <a:t>资料来源：README.md；OFFICIAL_V100_RESULT.md；PREFILL_V100_RESULT.md；V100_STRICT_RESULT.md。</a:t>
             </a:r>
           </a:p>
         </p:txBody>
@@ -587,7 +627,27 @@
           <a:lstStyle xmlns:a="http://schemas.openxmlformats.org/drawingml/2006/main"/>
           <a:p xmlns:a="http://schemas.openxmlformats.org/drawingml/2006/main">
             <a:r>
-              <a:t>架构依据：experiments/kda_repro/official_v100/agent_controller.py 与项目 README.md。结构化设计由控制器降为审查过的 sm70 Triton 模板。</a:t>
+              <a:t>这一页是整体架构。最左边是任务契约和普通基线，它们告诉系统输入输出是什么、结果要满足什么误差。Agent 先分析性能瓶颈，然后给出结构化设计，比如要不要融合、ROWS 取多少、使用几个 warps。控制器再把这些选择转换成受限制的 Triton 代码。</a:t>
+            </a:r>
+          </a:p>
+          <a:p xmlns:a="http://schemas.openxmlformats.org/drawingml/2006/main">
+            <a:r>
+              <a:t/>
+            </a:r>
+          </a:p>
+          <a:p xmlns:a="http://schemas.openxmlformats.org/drawingml/2006/main">
+            <a:r>
+              <a:t>候选生成后，系统会自动检查正确性和性能。只有全部测试通过而且确实更快，候选才会晋级。下面三项是整个流程的基础：官方 reference 和 workload 提供标准答案，V100 负责真实运行，实验记录保存每一步证据。</a:t>
+            </a:r>
+          </a:p>
+          <a:p xmlns:a="http://schemas.openxmlformats.org/drawingml/2006/main">
+            <a:r>
+              <a:t/>
+            </a:r>
+          </a:p>
+          <a:p xmlns:a="http://schemas.openxmlformats.org/drawingml/2006/main">
+            <a:r>
+              <a:t>资料来源：agent_controller.py；项目 README.md。</a:t>
             </a:r>
           </a:p>
         </p:txBody>
@@ -657,7 +717,27 @@
           <a:lstStyle xmlns:a="http://schemas.openxmlformats.org/drawingml/2006/main"/>
           <a:p xmlns:a="http://schemas.openxmlformats.org/drawingml/2006/main">
             <a:r>
-              <a:t>流程依据：agent_controller.py。普通基线实验中，直接整核生成因输出长度限制失败；结构化设计请求成功，并由控制器自动完成后续验证和晋级。</a:t>
+              <a:t>这里按顺序讲一下 Agent 流程。第一步读任务和当前最佳实现，第二步分析瓶颈并选择设计。然后系统生成候选，先做静态检查，再用少量输入做冒烟测试。冒烟通过后，才运行全部官方 workload。</a:t>
+            </a:r>
+          </a:p>
+          <a:p xmlns:a="http://schemas.openxmlformats.org/drawingml/2006/main">
+            <a:r>
+              <a:t/>
+            </a:r>
+          </a:p>
+          <a:p xmlns:a="http://schemas.openxmlformats.org/drawingml/2006/main">
+            <a:r>
+              <a:t>性能测试采用基线和候选交替计时，尽量减少 GPU 波动带来的误判。最后同时满足正确、分支通过、真实性能更快和提升门槛，候选才会晋级。失败也不会白跑，原因、模型响应和原始计时都会保存，方便下一轮改进。</a:t>
+            </a:r>
+          </a:p>
+          <a:p xmlns:a="http://schemas.openxmlformats.org/drawingml/2006/main">
+            <a:r>
+              <a:t/>
+            </a:r>
+          </a:p>
+          <a:p xmlns:a="http://schemas.openxmlformats.org/drawingml/2006/main">
+            <a:r>
+              <a:t>资料来源：agent_controller.py；candidates.jsonl。</a:t>
             </a:r>
           </a:p>
         </p:txBody>
@@ -727,7 +807,27 @@
           <a:lstStyle xmlns:a="http://schemas.openxmlformats.org/drawingml/2006/main"/>
           <a:p xmlns:a="http://schemas.openxmlformats.org/drawingml/2006/main">
             <a:r>
-              <a:t>代码与技术依据：gdn_decode_torch_seed.py、gdn_decode.py、AGENT_ORDINARY_BASELINE_V100_RESULT.md。候选使用受限模板，Agent选择设计和调度，不代表从空白生成完整内核。</a:t>
+              <a:t>这一页说明性能为什么会提升。普通 PyTorch 写法容易产生多个中间张量，状态矩阵会在显存里来回读写。Agent 选择把门控、归约、状态更新和输出融合到一个 Triton 内核里，并把原来的状态更新公式做等价化简。</a:t>
+            </a:r>
+          </a:p>
+          <a:p xmlns:a="http://schemas.openxmlformats.org/drawingml/2006/main">
+            <a:r>
+              <a:t/>
+            </a:r>
+          </a:p>
+          <a:p xmlns:a="http://schemas.openxmlformats.org/drawingml/2006/main">
+            <a:r>
+              <a:t>调度上选择 ROWS 等于 4、4 个 warps。V100 没有原生 BF16 算术支持，所以代码还处理了 BF16 的读取和舍入，主要状态继续使用 FP32 保证精度。最后仍然用官方 reference 和全部输入验证，不能因为代码看起来更快就直接采用。</a:t>
+            </a:r>
+          </a:p>
+          <a:p xmlns:a="http://schemas.openxmlformats.org/drawingml/2006/main">
+            <a:r>
+              <a:t/>
+            </a:r>
+          </a:p>
+          <a:p xmlns:a="http://schemas.openxmlformats.org/drawingml/2006/main">
+            <a:r>
+              <a:t>资料来源：gdn_decode_torch_seed.py；gdn_decode.py；AGENT_ORDINARY_BASELINE_V100_RESULT.md。</a:t>
             </a:r>
           </a:p>
         </p:txBody>
@@ -797,7 +897,27 @@
           <a:lstStyle xmlns:a="http://schemas.openxmlformats.org/drawingml/2006/main"/>
           <a:p xmlns:a="http://schemas.openxmlformats.org/drawingml/2006/main">
             <a:r>
-              <a:t>来源：decode-ordinary-structured/runs/0002-agent-full.json。配对基线 0.256052511309 ms，候选 0.023308402967 ms，加速 10.985416361365×。强 Triton 增量来自三轮配对复测 0.46%；Prefill 为 1.454%。</a:t>
+              <a:t>最后看性能。普通 PyTorch 的配对基线是 0.256053 毫秒，Agent 选择的 Triton 候选是 0.023308 毫秒，对应 10.985 倍加速。54 组 workload 里候选全部更快，同时 54 组正确性和 3 个额外分支也全部通过。</a:t>
+            </a:r>
+          </a:p>
+          <a:p xmlns:a="http://schemas.openxmlformats.org/drawingml/2006/main">
+            <a:r>
+              <a:t/>
+            </a:r>
+          </a:p>
+          <a:p xmlns:a="http://schemas.openxmlformats.org/drawingml/2006/main">
+            <a:r>
+              <a:t>这里要强调两个性能口径。相对普通 PyTorch，融合带来的总收益很大，能够展示自动优化流程的完整价值。相对已经很强的 Triton 基线，同一个候选只提升约 0.46%；Prefill 相对强基线提升 1.454%。所以后续工作的重点，是扩大搜索空间，让 Agent 在强基线上也能持续找到更好的设计。</a:t>
+            </a:r>
+          </a:p>
+          <a:p xmlns:a="http://schemas.openxmlformats.org/drawingml/2006/main">
+            <a:r>
+              <a:t/>
+            </a:r>
+          </a:p>
+          <a:p xmlns:a="http://schemas.openxmlformats.org/drawingml/2006/main">
+            <a:r>
+              <a:t>资料来源：decode-ordinary-structured/runs/0002-agent-full.json；AGENT_V100_RESULT.md；AGENT_PREFILL_V100_RESULT.md。</a:t>
             </a:r>
           </a:p>
         </p:txBody>
@@ -865,7 +985,7 @@
   </p:cSld>
   <p:clrMap bg1="lt1" tx1="dk1" bg2="lt2" tx2="dk2" accent1="accent1" accent2="accent2" accent3="accent3" accent4="accent4" accent5="accent5" accent6="accent6" hlink="hlink" folHlink="folHlink"/>
   <p:sldLayoutIdLst>
-    <p:sldLayoutId xmlns:r="http://schemas.openxmlformats.org/officeDocument/2006/relationships" id="2147483649" r:id="R2df7b1056dc64bdb"/>
+    <p:sldLayoutId xmlns:r="http://schemas.openxmlformats.org/officeDocument/2006/relationships" id="2147483649" r:id="R43037c4e630b4ffd"/>
   </p:sldLayoutIdLst>
   <p:txStyles>
     <p:titleStyle>
@@ -1676,6 +1796,7 @@
           <a:lstStyle xmlns:a="http://schemas.openxmlformats.org/drawingml/2006/main"/>
           <a:p xmlns:a="http://schemas.openxmlformats.org/drawingml/2006/main">
             <a:pPr algn="l">
+              <a:buNone/>
               <a:defRPr sz="4350" b="1">
                 <a:solidFill>
                   <a:srgbClr val="F6FAFE"/>
@@ -1733,6 +1854,7 @@
           <a:lstStyle xmlns:a="http://schemas.openxmlformats.org/drawingml/2006/main"/>
           <a:p xmlns:a="http://schemas.openxmlformats.org/drawingml/2006/main">
             <a:pPr algn="l">
+              <a:buNone/>
               <a:defRPr sz="1950" b="0">
                 <a:solidFill>
                   <a:srgbClr val="AFC1D4"/>
@@ -1821,6 +1943,7 @@
           <a:lstStyle xmlns:a="http://schemas.openxmlformats.org/drawingml/2006/main"/>
           <a:p xmlns:a="http://schemas.openxmlformats.org/drawingml/2006/main">
             <a:pPr algn="l">
+              <a:buNone/>
               <a:defRPr sz="1575" b="0">
                 <a:solidFill>
                   <a:srgbClr val="4EA7FF"/>
@@ -1878,6 +2001,7 @@
           <a:lstStyle xmlns:a="http://schemas.openxmlformats.org/drawingml/2006/main"/>
           <a:p xmlns:a="http://schemas.openxmlformats.org/drawingml/2006/main">
             <a:pPr algn="ctr">
+              <a:buNone/>
               <a:defRPr sz="4800" b="1">
                 <a:solidFill>
                   <a:srgbClr val="2DD4BF"/>
@@ -1935,6 +2059,7 @@
           <a:lstStyle xmlns:a="http://schemas.openxmlformats.org/drawingml/2006/main"/>
           <a:p xmlns:a="http://schemas.openxmlformats.org/drawingml/2006/main">
             <a:pPr algn="ctr">
+              <a:buNone/>
               <a:defRPr sz="1500" b="0">
                 <a:solidFill>
                   <a:srgbClr val="AFC1D4"/>
@@ -1958,6 +2083,7 @@
           </a:p>
           <a:p xmlns:a="http://schemas.openxmlformats.org/drawingml/2006/main">
             <a:pPr algn="ctr">
+              <a:buNone/>
               <a:defRPr sz="1500" b="0">
                 <a:solidFill>
                   <a:srgbClr val="AFC1D4"/>
@@ -2015,6 +2141,7 @@
           <a:lstStyle xmlns:a="http://schemas.openxmlformats.org/drawingml/2006/main"/>
           <a:p xmlns:a="http://schemas.openxmlformats.org/drawingml/2006/main">
             <a:pPr algn="l">
+              <a:buNone/>
               <a:defRPr sz="1275" b="0">
                 <a:solidFill>
                   <a:srgbClr val="AFC1D4"/>
@@ -2101,6 +2228,7 @@
           <a:lstStyle xmlns:a="http://schemas.openxmlformats.org/drawingml/2006/main"/>
           <a:p xmlns:a="http://schemas.openxmlformats.org/drawingml/2006/main">
             <a:pPr algn="l">
+              <a:buNone/>
               <a:defRPr sz="3000" b="1">
                 <a:solidFill>
                   <a:srgbClr val="F6FAFE"/>
@@ -2189,6 +2317,7 @@
           <a:lstStyle xmlns:a="http://schemas.openxmlformats.org/drawingml/2006/main"/>
           <a:p xmlns:a="http://schemas.openxmlformats.org/drawingml/2006/main">
             <a:pPr algn="l">
+              <a:buNone/>
               <a:defRPr sz="1350" b="0">
                 <a:solidFill>
                   <a:srgbClr val="AFC1D4"/>
@@ -2246,6 +2375,7 @@
           <a:lstStyle xmlns:a="http://schemas.openxmlformats.org/drawingml/2006/main"/>
           <a:p xmlns:a="http://schemas.openxmlformats.org/drawingml/2006/main">
             <a:pPr algn="l">
+              <a:buNone/>
               <a:defRPr sz="5400" b="1">
                 <a:solidFill>
                   <a:srgbClr val="2DD4BF"/>
@@ -2303,6 +2433,7 @@
           <a:lstStyle xmlns:a="http://schemas.openxmlformats.org/drawingml/2006/main"/>
           <a:p xmlns:a="http://schemas.openxmlformats.org/drawingml/2006/main">
             <a:pPr algn="l">
+              <a:buNone/>
               <a:defRPr sz="1725" b="1">
                 <a:solidFill>
                   <a:srgbClr val="F6FAFE"/>
@@ -2360,6 +2491,7 @@
           <a:lstStyle xmlns:a="http://schemas.openxmlformats.org/drawingml/2006/main"/>
           <a:p xmlns:a="http://schemas.openxmlformats.org/drawingml/2006/main">
             <a:pPr algn="l">
+              <a:buNone/>
               <a:defRPr sz="1425" b="0">
                 <a:solidFill>
                   <a:srgbClr val="AFC1D4"/>
@@ -2448,6 +2580,7 @@
           <a:lstStyle xmlns:a="http://schemas.openxmlformats.org/drawingml/2006/main"/>
           <a:p xmlns:a="http://schemas.openxmlformats.org/drawingml/2006/main">
             <a:pPr algn="l">
+              <a:buNone/>
               <a:defRPr sz="2850" b="1">
                 <a:solidFill>
                   <a:srgbClr val="55D187"/>
@@ -2505,6 +2638,7 @@
           <a:lstStyle xmlns:a="http://schemas.openxmlformats.org/drawingml/2006/main"/>
           <a:p xmlns:a="http://schemas.openxmlformats.org/drawingml/2006/main">
             <a:pPr algn="l">
+              <a:buNone/>
               <a:defRPr sz="1500" b="0">
                 <a:solidFill>
                   <a:srgbClr val="F6FAFE"/>
@@ -2562,6 +2696,7 @@
           <a:lstStyle xmlns:a="http://schemas.openxmlformats.org/drawingml/2006/main"/>
           <a:p xmlns:a="http://schemas.openxmlformats.org/drawingml/2006/main">
             <a:pPr algn="l">
+              <a:buNone/>
               <a:defRPr sz="2850" b="1">
                 <a:solidFill>
                   <a:srgbClr val="4EA7FF"/>
@@ -2619,6 +2754,7 @@
           <a:lstStyle xmlns:a="http://schemas.openxmlformats.org/drawingml/2006/main"/>
           <a:p xmlns:a="http://schemas.openxmlformats.org/drawingml/2006/main">
             <a:pPr algn="l">
+              <a:buNone/>
               <a:defRPr sz="1500" b="0">
                 <a:solidFill>
                   <a:srgbClr val="F6FAFE"/>
@@ -2676,6 +2812,7 @@
           <a:lstStyle xmlns:a="http://schemas.openxmlformats.org/drawingml/2006/main"/>
           <a:p xmlns:a="http://schemas.openxmlformats.org/drawingml/2006/main">
             <a:pPr algn="l">
+              <a:buNone/>
               <a:defRPr sz="2850" b="1">
                 <a:solidFill>
                   <a:srgbClr val="FFB454"/>
@@ -2733,6 +2870,7 @@
           <a:lstStyle xmlns:a="http://schemas.openxmlformats.org/drawingml/2006/main"/>
           <a:p xmlns:a="http://schemas.openxmlformats.org/drawingml/2006/main">
             <a:pPr algn="l">
+              <a:buNone/>
               <a:defRPr sz="1500" b="0">
                 <a:solidFill>
                   <a:srgbClr val="F6FAFE"/>
@@ -2790,6 +2928,7 @@
           <a:lstStyle xmlns:a="http://schemas.openxmlformats.org/drawingml/2006/main"/>
           <a:p xmlns:a="http://schemas.openxmlformats.org/drawingml/2006/main">
             <a:pPr algn="l">
+              <a:buNone/>
               <a:defRPr sz="1350" b="0">
                 <a:solidFill>
                   <a:srgbClr val="AFC1D4"/>
@@ -2876,6 +3015,7 @@
           <a:lstStyle xmlns:a="http://schemas.openxmlformats.org/drawingml/2006/main"/>
           <a:p xmlns:a="http://schemas.openxmlformats.org/drawingml/2006/main">
             <a:pPr algn="l">
+              <a:buNone/>
               <a:defRPr sz="3000" b="1">
                 <a:solidFill>
                   <a:srgbClr val="F6FAFE"/>
@@ -2964,6 +3104,7 @@
           <a:lstStyle xmlns:a="http://schemas.openxmlformats.org/drawingml/2006/main"/>
           <a:p xmlns:a="http://schemas.openxmlformats.org/drawingml/2006/main">
             <a:pPr algn="l">
+              <a:buNone/>
               <a:defRPr sz="1350" b="0">
                 <a:solidFill>
                   <a:srgbClr val="AFC1D4"/>
@@ -3028,6 +3169,7 @@
           <a:lstStyle xmlns:a="http://schemas.openxmlformats.org/drawingml/2006/main"/>
           <a:p xmlns:a="http://schemas.openxmlformats.org/drawingml/2006/main">
             <a:pPr algn="ctr">
+              <a:buNone/>
               <a:defRPr sz="1575" b="1">
                 <a:solidFill>
                   <a:srgbClr val="F6FAFE"/>
@@ -3051,6 +3193,7 @@
           </a:p>
           <a:p xmlns:a="http://schemas.openxmlformats.org/drawingml/2006/main">
             <a:pPr algn="ctr">
+              <a:buNone/>
               <a:defRPr sz="1575" b="1">
                 <a:solidFill>
                   <a:srgbClr val="F6FAFE"/>
@@ -3115,6 +3258,7 @@
           <a:lstStyle xmlns:a="http://schemas.openxmlformats.org/drawingml/2006/main"/>
           <a:p xmlns:a="http://schemas.openxmlformats.org/drawingml/2006/main">
             <a:pPr algn="ctr">
+              <a:buNone/>
               <a:defRPr sz="1575" b="1">
                 <a:solidFill>
                   <a:srgbClr val="F6FAFE"/>
@@ -3138,6 +3282,7 @@
           </a:p>
           <a:p xmlns:a="http://schemas.openxmlformats.org/drawingml/2006/main">
             <a:pPr algn="ctr">
+              <a:buNone/>
               <a:defRPr sz="1575" b="1">
                 <a:solidFill>
                   <a:srgbClr val="F6FAFE"/>
@@ -3202,6 +3347,7 @@
           <a:lstStyle xmlns:a="http://schemas.openxmlformats.org/drawingml/2006/main"/>
           <a:p xmlns:a="http://schemas.openxmlformats.org/drawingml/2006/main">
             <a:pPr algn="ctr">
+              <a:buNone/>
               <a:defRPr sz="1575" b="1">
                 <a:solidFill>
                   <a:srgbClr val="F6FAFE"/>
@@ -3225,6 +3371,7 @@
           </a:p>
           <a:p xmlns:a="http://schemas.openxmlformats.org/drawingml/2006/main">
             <a:pPr algn="ctr">
+              <a:buNone/>
               <a:defRPr sz="1575" b="1">
                 <a:solidFill>
                   <a:srgbClr val="F6FAFE"/>
@@ -3289,6 +3436,7 @@
           <a:lstStyle xmlns:a="http://schemas.openxmlformats.org/drawingml/2006/main"/>
           <a:p xmlns:a="http://schemas.openxmlformats.org/drawingml/2006/main">
             <a:pPr algn="ctr">
+              <a:buNone/>
               <a:defRPr sz="1575" b="1">
                 <a:solidFill>
                   <a:srgbClr val="F6FAFE"/>
@@ -3312,6 +3460,7 @@
           </a:p>
           <a:p xmlns:a="http://schemas.openxmlformats.org/drawingml/2006/main">
             <a:pPr algn="ctr">
+              <a:buNone/>
               <a:defRPr sz="1575" b="1">
                 <a:solidFill>
                   <a:srgbClr val="F6FAFE"/>
@@ -3376,6 +3525,7 @@
           <a:lstStyle xmlns:a="http://schemas.openxmlformats.org/drawingml/2006/main"/>
           <a:p xmlns:a="http://schemas.openxmlformats.org/drawingml/2006/main">
             <a:pPr algn="ctr">
+              <a:buNone/>
               <a:defRPr sz="1575" b="1">
                 <a:solidFill>
                   <a:srgbClr val="F6FAFE"/>
@@ -3399,6 +3549,7 @@
           </a:p>
           <a:p xmlns:a="http://schemas.openxmlformats.org/drawingml/2006/main">
             <a:pPr algn="ctr">
+              <a:buNone/>
               <a:defRPr sz="1575" b="1">
                 <a:solidFill>
                   <a:srgbClr val="F6FAFE"/>
@@ -3463,6 +3614,7 @@
           <a:lstStyle xmlns:a="http://schemas.openxmlformats.org/drawingml/2006/main"/>
           <a:p xmlns:a="http://schemas.openxmlformats.org/drawingml/2006/main">
             <a:pPr algn="ctr">
+              <a:buNone/>
               <a:defRPr sz="1500" b="1">
                 <a:solidFill>
                   <a:srgbClr val="F6FAFE"/>
@@ -3486,6 +3638,7 @@
           </a:p>
           <a:p xmlns:a="http://schemas.openxmlformats.org/drawingml/2006/main">
             <a:pPr algn="ctr">
+              <a:buNone/>
               <a:defRPr sz="1500" b="1">
                 <a:solidFill>
                   <a:srgbClr val="F6FAFE"/>
@@ -3511,7 +3664,7 @@
       </p:sp>
       <p:cxnSp>
         <p:nvCxnSpPr>
-          <p:cNvPr id="32" name=""/>
+          <p:cNvPr id="46" name=""/>
           <p:cNvCxnSpPr>
             <a:stCxn xmlns:a="http://schemas.openxmlformats.org/drawingml/2006/main" id="4" idx="3"/>
             <a:endCxn xmlns:a="http://schemas.openxmlformats.org/drawingml/2006/main" id="5" idx="1"/>
@@ -3537,7 +3690,7 @@
       </p:cxnSp>
       <p:cxnSp>
         <p:nvCxnSpPr>
-          <p:cNvPr id="33" name=""/>
+          <p:cNvPr id="47" name=""/>
           <p:cNvCxnSpPr>
             <a:stCxn xmlns:a="http://schemas.openxmlformats.org/drawingml/2006/main" id="5" idx="3"/>
             <a:endCxn xmlns:a="http://schemas.openxmlformats.org/drawingml/2006/main" id="6" idx="1"/>
@@ -3563,7 +3716,7 @@
       </p:cxnSp>
       <p:cxnSp>
         <p:nvCxnSpPr>
-          <p:cNvPr id="34" name=""/>
+          <p:cNvPr id="48" name=""/>
           <p:cNvCxnSpPr>
             <a:stCxn xmlns:a="http://schemas.openxmlformats.org/drawingml/2006/main" id="6" idx="3"/>
             <a:endCxn xmlns:a="http://schemas.openxmlformats.org/drawingml/2006/main" id="7" idx="1"/>
@@ -3589,7 +3742,7 @@
       </p:cxnSp>
       <p:cxnSp>
         <p:nvCxnSpPr>
-          <p:cNvPr id="35" name=""/>
+          <p:cNvPr id="49" name=""/>
           <p:cNvCxnSpPr>
             <a:stCxn xmlns:a="http://schemas.openxmlformats.org/drawingml/2006/main" id="7" idx="3"/>
             <a:endCxn xmlns:a="http://schemas.openxmlformats.org/drawingml/2006/main" id="8" idx="1"/>
@@ -3615,7 +3768,7 @@
       </p:cxnSp>
       <p:cxnSp>
         <p:nvCxnSpPr>
-          <p:cNvPr id="36" name=""/>
+          <p:cNvPr id="50" name=""/>
           <p:cNvCxnSpPr>
             <a:stCxn xmlns:a="http://schemas.openxmlformats.org/drawingml/2006/main" id="8" idx="3"/>
             <a:endCxn xmlns:a="http://schemas.openxmlformats.org/drawingml/2006/main" id="9" idx="1"/>
@@ -3673,6 +3826,7 @@
           <a:lstStyle xmlns:a="http://schemas.openxmlformats.org/drawingml/2006/main"/>
           <a:p xmlns:a="http://schemas.openxmlformats.org/drawingml/2006/main">
             <a:pPr algn="l">
+              <a:buNone/>
               <a:defRPr sz="1875" b="1">
                 <a:solidFill>
                   <a:srgbClr val="F6FAFE"/>
@@ -3761,6 +3915,7 @@
           <a:lstStyle xmlns:a="http://schemas.openxmlformats.org/drawingml/2006/main"/>
           <a:p xmlns:a="http://schemas.openxmlformats.org/drawingml/2006/main">
             <a:pPr algn="l">
+              <a:buNone/>
               <a:defRPr sz="1500" b="1">
                 <a:solidFill>
                   <a:srgbClr val="4EA7FF"/>
@@ -3818,6 +3973,7 @@
           <a:lstStyle xmlns:a="http://schemas.openxmlformats.org/drawingml/2006/main"/>
           <a:p xmlns:a="http://schemas.openxmlformats.org/drawingml/2006/main">
             <a:pPr algn="l">
+              <a:buNone/>
               <a:defRPr sz="1350" b="0">
                 <a:solidFill>
                   <a:srgbClr val="AFC1D4"/>
@@ -3875,6 +4031,7 @@
           <a:lstStyle xmlns:a="http://schemas.openxmlformats.org/drawingml/2006/main"/>
           <a:p xmlns:a="http://schemas.openxmlformats.org/drawingml/2006/main">
             <a:pPr algn="l">
+              <a:buNone/>
               <a:defRPr sz="1500" b="1">
                 <a:solidFill>
                   <a:srgbClr val="2DD4BF"/>
@@ -3932,6 +4089,7 @@
           <a:lstStyle xmlns:a="http://schemas.openxmlformats.org/drawingml/2006/main"/>
           <a:p xmlns:a="http://schemas.openxmlformats.org/drawingml/2006/main">
             <a:pPr algn="l">
+              <a:buNone/>
               <a:defRPr sz="1350" b="0">
                 <a:solidFill>
                   <a:srgbClr val="AFC1D4"/>
@@ -3989,6 +4147,7 @@
           <a:lstStyle xmlns:a="http://schemas.openxmlformats.org/drawingml/2006/main"/>
           <a:p xmlns:a="http://schemas.openxmlformats.org/drawingml/2006/main">
             <a:pPr algn="l">
+              <a:buNone/>
               <a:defRPr sz="1500" b="1">
                 <a:solidFill>
                   <a:srgbClr val="55D187"/>
@@ -4046,6 +4205,7 @@
           <a:lstStyle xmlns:a="http://schemas.openxmlformats.org/drawingml/2006/main"/>
           <a:p xmlns:a="http://schemas.openxmlformats.org/drawingml/2006/main">
             <a:pPr algn="l">
+              <a:buNone/>
               <a:defRPr sz="1350" b="0">
                 <a:solidFill>
                   <a:srgbClr val="AFC1D4"/>
@@ -4132,6 +4292,7 @@
           <a:lstStyle xmlns:a="http://schemas.openxmlformats.org/drawingml/2006/main"/>
           <a:p xmlns:a="http://schemas.openxmlformats.org/drawingml/2006/main">
             <a:pPr algn="l">
+              <a:buNone/>
               <a:defRPr sz="3000" b="1">
                 <a:solidFill>
                   <a:srgbClr val="F6FAFE"/>
@@ -4220,6 +4381,7 @@
           <a:lstStyle xmlns:a="http://schemas.openxmlformats.org/drawingml/2006/main"/>
           <a:p xmlns:a="http://schemas.openxmlformats.org/drawingml/2006/main">
             <a:pPr algn="l">
+              <a:buNone/>
               <a:defRPr sz="1350" b="0">
                 <a:solidFill>
                   <a:srgbClr val="AFC1D4"/>
@@ -4307,6 +4469,7 @@
           <a:lstStyle xmlns:a="http://schemas.openxmlformats.org/drawingml/2006/main"/>
           <a:p xmlns:a="http://schemas.openxmlformats.org/drawingml/2006/main">
             <a:pPr algn="ctr">
+              <a:buNone/>
               <a:defRPr sz="1500" b="1">
                 <a:solidFill>
                   <a:srgbClr val="07111F"/>
@@ -4364,6 +4527,7 @@
           <a:lstStyle xmlns:a="http://schemas.openxmlformats.org/drawingml/2006/main"/>
           <a:p xmlns:a="http://schemas.openxmlformats.org/drawingml/2006/main">
             <a:pPr algn="l">
+              <a:buNone/>
               <a:defRPr sz="1650" b="0">
                 <a:solidFill>
                   <a:srgbClr val="F6FAFE"/>
@@ -4482,6 +4646,7 @@
           <a:lstStyle xmlns:a="http://schemas.openxmlformats.org/drawingml/2006/main"/>
           <a:p xmlns:a="http://schemas.openxmlformats.org/drawingml/2006/main">
             <a:pPr algn="ctr">
+              <a:buNone/>
               <a:defRPr sz="1500" b="1">
                 <a:solidFill>
                   <a:srgbClr val="07111F"/>
@@ -4539,6 +4704,7 @@
           <a:lstStyle xmlns:a="http://schemas.openxmlformats.org/drawingml/2006/main"/>
           <a:p xmlns:a="http://schemas.openxmlformats.org/drawingml/2006/main">
             <a:pPr algn="l">
+              <a:buNone/>
               <a:defRPr sz="1650" b="0">
                 <a:solidFill>
                   <a:srgbClr val="F6FAFE"/>
@@ -4657,6 +4823,7 @@
           <a:lstStyle xmlns:a="http://schemas.openxmlformats.org/drawingml/2006/main"/>
           <a:p xmlns:a="http://schemas.openxmlformats.org/drawingml/2006/main">
             <a:pPr algn="ctr">
+              <a:buNone/>
               <a:defRPr sz="1500" b="1">
                 <a:solidFill>
                   <a:srgbClr val="07111F"/>
@@ -4714,6 +4881,7 @@
           <a:lstStyle xmlns:a="http://schemas.openxmlformats.org/drawingml/2006/main"/>
           <a:p xmlns:a="http://schemas.openxmlformats.org/drawingml/2006/main">
             <a:pPr algn="l">
+              <a:buNone/>
               <a:defRPr sz="1650" b="0">
                 <a:solidFill>
                   <a:srgbClr val="F6FAFE"/>
@@ -4832,6 +5000,7 @@
           <a:lstStyle xmlns:a="http://schemas.openxmlformats.org/drawingml/2006/main"/>
           <a:p xmlns:a="http://schemas.openxmlformats.org/drawingml/2006/main">
             <a:pPr algn="ctr">
+              <a:buNone/>
               <a:defRPr sz="1500" b="1">
                 <a:solidFill>
                   <a:srgbClr val="07111F"/>
@@ -4889,6 +5058,7 @@
           <a:lstStyle xmlns:a="http://schemas.openxmlformats.org/drawingml/2006/main"/>
           <a:p xmlns:a="http://schemas.openxmlformats.org/drawingml/2006/main">
             <a:pPr algn="l">
+              <a:buNone/>
               <a:defRPr sz="1650" b="0">
                 <a:solidFill>
                   <a:srgbClr val="F6FAFE"/>
@@ -5007,6 +5177,7 @@
           <a:lstStyle xmlns:a="http://schemas.openxmlformats.org/drawingml/2006/main"/>
           <a:p xmlns:a="http://schemas.openxmlformats.org/drawingml/2006/main">
             <a:pPr algn="ctr">
+              <a:buNone/>
               <a:defRPr sz="1500" b="1">
                 <a:solidFill>
                   <a:srgbClr val="07111F"/>
@@ -5064,6 +5235,7 @@
           <a:lstStyle xmlns:a="http://schemas.openxmlformats.org/drawingml/2006/main"/>
           <a:p xmlns:a="http://schemas.openxmlformats.org/drawingml/2006/main">
             <a:pPr algn="l">
+              <a:buNone/>
               <a:defRPr sz="1650" b="0">
                 <a:solidFill>
                   <a:srgbClr val="F6FAFE"/>
@@ -5182,6 +5354,7 @@
           <a:lstStyle xmlns:a="http://schemas.openxmlformats.org/drawingml/2006/main"/>
           <a:p xmlns:a="http://schemas.openxmlformats.org/drawingml/2006/main">
             <a:pPr algn="ctr">
+              <a:buNone/>
               <a:defRPr sz="1500" b="1">
                 <a:solidFill>
                   <a:srgbClr val="07111F"/>
@@ -5239,6 +5412,7 @@
           <a:lstStyle xmlns:a="http://schemas.openxmlformats.org/drawingml/2006/main"/>
           <a:p xmlns:a="http://schemas.openxmlformats.org/drawingml/2006/main">
             <a:pPr algn="l">
+              <a:buNone/>
               <a:defRPr sz="1650" b="0">
                 <a:solidFill>
                   <a:srgbClr val="F6FAFE"/>
@@ -5357,6 +5531,7 @@
           <a:lstStyle xmlns:a="http://schemas.openxmlformats.org/drawingml/2006/main"/>
           <a:p xmlns:a="http://schemas.openxmlformats.org/drawingml/2006/main">
             <a:pPr algn="ctr">
+              <a:buNone/>
               <a:defRPr sz="1500" b="1">
                 <a:solidFill>
                   <a:srgbClr val="07111F"/>
@@ -5414,6 +5589,7 @@
           <a:lstStyle xmlns:a="http://schemas.openxmlformats.org/drawingml/2006/main"/>
           <a:p xmlns:a="http://schemas.openxmlformats.org/drawingml/2006/main">
             <a:pPr algn="l">
+              <a:buNone/>
               <a:defRPr sz="1650" b="1">
                 <a:solidFill>
                   <a:srgbClr val="F6FAFE"/>
@@ -5471,6 +5647,7 @@
           <a:lstStyle xmlns:a="http://schemas.openxmlformats.org/drawingml/2006/main"/>
           <a:p xmlns:a="http://schemas.openxmlformats.org/drawingml/2006/main">
             <a:pPr algn="l">
+              <a:buNone/>
               <a:defRPr sz="2100" b="1">
                 <a:solidFill>
                   <a:srgbClr val="F6FAFE"/>
@@ -5559,6 +5736,7 @@
           <a:lstStyle xmlns:a="http://schemas.openxmlformats.org/drawingml/2006/main"/>
           <a:p xmlns:a="http://schemas.openxmlformats.org/drawingml/2006/main">
             <a:pPr algn="l">
+              <a:buNone/>
               <a:defRPr sz="1650" b="1">
                 <a:solidFill>
                   <a:srgbClr val="55D187"/>
@@ -5616,6 +5794,7 @@
           <a:lstStyle xmlns:a="http://schemas.openxmlformats.org/drawingml/2006/main"/>
           <a:p xmlns:a="http://schemas.openxmlformats.org/drawingml/2006/main">
             <a:pPr algn="l">
+              <a:buNone/>
               <a:defRPr sz="1650" b="1">
                 <a:solidFill>
                   <a:srgbClr val="55D187"/>
@@ -5673,6 +5852,7 @@
           <a:lstStyle xmlns:a="http://schemas.openxmlformats.org/drawingml/2006/main"/>
           <a:p xmlns:a="http://schemas.openxmlformats.org/drawingml/2006/main">
             <a:pPr algn="l">
+              <a:buNone/>
               <a:defRPr sz="1650" b="1">
                 <a:solidFill>
                   <a:srgbClr val="4EA7FF"/>
@@ -5730,6 +5910,7 @@
           <a:lstStyle xmlns:a="http://schemas.openxmlformats.org/drawingml/2006/main"/>
           <a:p xmlns:a="http://schemas.openxmlformats.org/drawingml/2006/main">
             <a:pPr algn="l">
+              <a:buNone/>
               <a:defRPr sz="1650" b="1">
                 <a:solidFill>
                   <a:srgbClr val="2DD4BF"/>
@@ -5787,6 +5968,7 @@
           <a:lstStyle xmlns:a="http://schemas.openxmlformats.org/drawingml/2006/main"/>
           <a:p xmlns:a="http://schemas.openxmlformats.org/drawingml/2006/main">
             <a:pPr algn="l">
+              <a:buNone/>
               <a:defRPr sz="1425" b="0">
                 <a:solidFill>
                   <a:srgbClr val="AFC1D4"/>
@@ -5810,6 +5992,7 @@
           </a:p>
           <a:p xmlns:a="http://schemas.openxmlformats.org/drawingml/2006/main">
             <a:pPr algn="l">
+              <a:buNone/>
               <a:defRPr sz="1425" b="0">
                 <a:solidFill>
                   <a:srgbClr val="AFC1D4"/>
@@ -5896,6 +6079,7 @@
           <a:lstStyle xmlns:a="http://schemas.openxmlformats.org/drawingml/2006/main"/>
           <a:p xmlns:a="http://schemas.openxmlformats.org/drawingml/2006/main">
             <a:pPr algn="l">
+              <a:buNone/>
               <a:defRPr sz="3000" b="1">
                 <a:solidFill>
                   <a:srgbClr val="F6FAFE"/>
@@ -5984,6 +6168,7 @@
           <a:lstStyle xmlns:a="http://schemas.openxmlformats.org/drawingml/2006/main"/>
           <a:p xmlns:a="http://schemas.openxmlformats.org/drawingml/2006/main">
             <a:pPr algn="l">
+              <a:buNone/>
               <a:defRPr sz="1350" b="0">
                 <a:solidFill>
                   <a:srgbClr val="AFC1D4"/>
@@ -6041,6 +6226,7 @@
           <a:lstStyle xmlns:a="http://schemas.openxmlformats.org/drawingml/2006/main"/>
           <a:p xmlns:a="http://schemas.openxmlformats.org/drawingml/2006/main">
             <a:pPr algn="l">
+              <a:buNone/>
               <a:defRPr sz="1800" b="1">
                 <a:solidFill>
                   <a:srgbClr val="AFC1D4"/>
@@ -6098,6 +6284,7 @@
           <a:lstStyle xmlns:a="http://schemas.openxmlformats.org/drawingml/2006/main"/>
           <a:p xmlns:a="http://schemas.openxmlformats.org/drawingml/2006/main">
             <a:pPr algn="l">
+              <a:buNone/>
               <a:defRPr sz="1425" b="0">
                 <a:solidFill>
                   <a:srgbClr val="F6FAFE"/>
@@ -6155,6 +6342,7 @@
           <a:lstStyle xmlns:a="http://schemas.openxmlformats.org/drawingml/2006/main"/>
           <a:p xmlns:a="http://schemas.openxmlformats.org/drawingml/2006/main">
             <a:pPr algn="l">
+              <a:buNone/>
               <a:defRPr sz="1575" b="0">
                 <a:solidFill>
                   <a:srgbClr val="D7E5F2"/>
@@ -6178,6 +6366,7 @@
           </a:p>
           <a:p xmlns:a="http://schemas.openxmlformats.org/drawingml/2006/main">
             <a:pPr algn="l">
+              <a:buNone/>
               <a:defRPr sz="1575" b="0">
                 <a:solidFill>
                   <a:srgbClr val="D7E5F2"/>
@@ -6201,6 +6390,7 @@
           </a:p>
           <a:p xmlns:a="http://schemas.openxmlformats.org/drawingml/2006/main">
             <a:pPr algn="l">
+              <a:buNone/>
               <a:defRPr sz="1575" b="0">
                 <a:solidFill>
                   <a:srgbClr val="D7E5F2"/>
@@ -6224,6 +6414,7 @@
           </a:p>
           <a:p xmlns:a="http://schemas.openxmlformats.org/drawingml/2006/main">
             <a:pPr algn="l">
+              <a:buNone/>
               <a:defRPr sz="1575" b="0">
                 <a:solidFill>
                   <a:srgbClr val="D7E5F2"/>
@@ -6281,6 +6472,7 @@
           <a:lstStyle xmlns:a="http://schemas.openxmlformats.org/drawingml/2006/main"/>
           <a:p xmlns:a="http://schemas.openxmlformats.org/drawingml/2006/main">
             <a:pPr algn="l">
+              <a:buNone/>
               <a:defRPr sz="1800" b="1">
                 <a:solidFill>
                   <a:srgbClr val="2DD4BF"/>
@@ -6338,6 +6530,7 @@
           <a:lstStyle xmlns:a="http://schemas.openxmlformats.org/drawingml/2006/main"/>
           <a:p xmlns:a="http://schemas.openxmlformats.org/drawingml/2006/main">
             <a:pPr algn="l">
+              <a:buNone/>
               <a:defRPr sz="1425" b="0">
                 <a:solidFill>
                   <a:srgbClr val="F6FAFE"/>
@@ -6395,6 +6588,7 @@
           <a:lstStyle xmlns:a="http://schemas.openxmlformats.org/drawingml/2006/main"/>
           <a:p xmlns:a="http://schemas.openxmlformats.org/drawingml/2006/main">
             <a:pPr algn="l">
+              <a:buNone/>
               <a:defRPr sz="1575" b="0">
                 <a:solidFill>
                   <a:srgbClr val="D7E5F2"/>
@@ -6418,6 +6612,7 @@
           </a:p>
           <a:p xmlns:a="http://schemas.openxmlformats.org/drawingml/2006/main">
             <a:pPr algn="l">
+              <a:buNone/>
               <a:defRPr sz="1575" b="0">
                 <a:solidFill>
                   <a:srgbClr val="D7E5F2"/>
@@ -6446,6 +6641,7 @@
           </a:p>
           <a:p xmlns:a="http://schemas.openxmlformats.org/drawingml/2006/main">
             <a:pPr algn="l">
+              <a:buNone/>
               <a:defRPr sz="1575" b="0">
                 <a:solidFill>
                   <a:srgbClr val="D7E5F2"/>
@@ -6469,6 +6665,7 @@
           </a:p>
           <a:p xmlns:a="http://schemas.openxmlformats.org/drawingml/2006/main">
             <a:pPr algn="l">
+              <a:buNone/>
               <a:defRPr sz="1575" b="0">
                 <a:solidFill>
                   <a:srgbClr val="D7E5F2"/>
@@ -6528,6 +6725,7 @@
           <a:lstStyle xmlns:a="http://schemas.openxmlformats.org/drawingml/2006/main"/>
           <a:p xmlns:a="http://schemas.openxmlformats.org/drawingml/2006/main">
             <a:pPr algn="ctr">
+              <a:buNone/>
               <a:defRPr sz="1275" b="1">
                 <a:solidFill>
                   <a:srgbClr val="07111F"/>
@@ -6616,6 +6814,7 @@
           <a:lstStyle xmlns:a="http://schemas.openxmlformats.org/drawingml/2006/main"/>
           <a:p xmlns:a="http://schemas.openxmlformats.org/drawingml/2006/main">
             <a:pPr algn="l">
+              <a:buNone/>
               <a:defRPr sz="1500" b="1">
                 <a:solidFill>
                   <a:srgbClr val="4EA7FF"/>
@@ -6673,6 +6872,7 @@
           <a:lstStyle xmlns:a="http://schemas.openxmlformats.org/drawingml/2006/main"/>
           <a:p xmlns:a="http://schemas.openxmlformats.org/drawingml/2006/main">
             <a:pPr algn="l">
+              <a:buNone/>
               <a:defRPr sz="1350" b="0">
                 <a:solidFill>
                   <a:srgbClr val="AFC1D4"/>
@@ -6730,6 +6930,7 @@
           <a:lstStyle xmlns:a="http://schemas.openxmlformats.org/drawingml/2006/main"/>
           <a:p xmlns:a="http://schemas.openxmlformats.org/drawingml/2006/main">
             <a:pPr algn="l">
+              <a:buNone/>
               <a:defRPr sz="1500" b="1">
                 <a:solidFill>
                   <a:srgbClr val="2DD4BF"/>
@@ -6787,6 +6988,7 @@
           <a:lstStyle xmlns:a="http://schemas.openxmlformats.org/drawingml/2006/main"/>
           <a:p xmlns:a="http://schemas.openxmlformats.org/drawingml/2006/main">
             <a:pPr algn="l">
+              <a:buNone/>
               <a:defRPr sz="1350" b="0">
                 <a:solidFill>
                   <a:srgbClr val="AFC1D4"/>
@@ -6844,6 +7046,7 @@
           <a:lstStyle xmlns:a="http://schemas.openxmlformats.org/drawingml/2006/main"/>
           <a:p xmlns:a="http://schemas.openxmlformats.org/drawingml/2006/main">
             <a:pPr algn="l">
+              <a:buNone/>
               <a:defRPr sz="1500" b="1">
                 <a:solidFill>
                   <a:srgbClr val="55D187"/>
@@ -6901,6 +7104,7 @@
           <a:lstStyle xmlns:a="http://schemas.openxmlformats.org/drawingml/2006/main"/>
           <a:p xmlns:a="http://schemas.openxmlformats.org/drawingml/2006/main">
             <a:pPr algn="l">
+              <a:buNone/>
               <a:defRPr sz="1350" b="0">
                 <a:solidFill>
                   <a:srgbClr val="AFC1D4"/>
@@ -6987,6 +7191,7 @@
           <a:lstStyle xmlns:a="http://schemas.openxmlformats.org/drawingml/2006/main"/>
           <a:p xmlns:a="http://schemas.openxmlformats.org/drawingml/2006/main">
             <a:pPr algn="l">
+              <a:buNone/>
               <a:defRPr sz="3000" b="1">
                 <a:solidFill>
                   <a:srgbClr val="10243A"/>
@@ -7075,6 +7280,7 @@
           <a:lstStyle xmlns:a="http://schemas.openxmlformats.org/drawingml/2006/main"/>
           <a:p xmlns:a="http://schemas.openxmlformats.org/drawingml/2006/main">
             <a:pPr algn="r">
+              <a:buNone/>
               <a:defRPr sz="1275" b="0">
                 <a:solidFill>
                   <a:srgbClr val="60758A"/>
@@ -7100,7 +7306,7 @@
       </p:sp>
       <p:graphicFrame>
         <p:nvGraphicFramePr>
-          <p:cNvPr id="15" name="Chart"/>
+          <p:cNvPr id="17" name="Chart"/>
           <p:cNvGraphicFramePr/>
           <p:nvPr/>
         </p:nvGraphicFramePr>
@@ -7110,7 +7316,7 @@
         </p:xfrm>
         <a:graphic xmlns:a="http://schemas.openxmlformats.org/drawingml/2006/main">
           <a:graphicData uri="http://schemas.openxmlformats.org/drawingml/2006/chart">
-            <c:chart xmlns:r="http://schemas.openxmlformats.org/officeDocument/2006/relationships" xmlns:c="http://schemas.openxmlformats.org/drawingml/2006/chart" r:id="Rf2d7a37327474465"/>
+            <c:chart xmlns:r="http://schemas.openxmlformats.org/officeDocument/2006/relationships" xmlns:c="http://schemas.openxmlformats.org/drawingml/2006/chart" r:id="Rf1918aae133646cf"/>
           </a:graphicData>
         </a:graphic>
       </p:graphicFrame>
@@ -7148,6 +7354,7 @@
           <a:lstStyle xmlns:a="http://schemas.openxmlformats.org/drawingml/2006/main"/>
           <a:p xmlns:a="http://schemas.openxmlformats.org/drawingml/2006/main">
             <a:pPr algn="ctr">
+              <a:buNone/>
               <a:defRPr sz="4650" b="1">
                 <a:solidFill>
                   <a:srgbClr val="0F8F80"/>
@@ -7205,6 +7412,7 @@
           <a:lstStyle xmlns:a="http://schemas.openxmlformats.org/drawingml/2006/main"/>
           <a:p xmlns:a="http://schemas.openxmlformats.org/drawingml/2006/main">
             <a:pPr algn="ctr">
+              <a:buNone/>
               <a:defRPr sz="1650" b="1">
                 <a:solidFill>
                   <a:srgbClr val="20384F"/>
@@ -7262,6 +7470,7 @@
           <a:lstStyle xmlns:a="http://schemas.openxmlformats.org/drawingml/2006/main"/>
           <a:p xmlns:a="http://schemas.openxmlformats.org/drawingml/2006/main">
             <a:pPr algn="ctr">
+              <a:buNone/>
               <a:defRPr sz="1500" b="0">
                 <a:solidFill>
                   <a:srgbClr val="60758A"/>
@@ -7285,6 +7494,7 @@
           </a:p>
           <a:p xmlns:a="http://schemas.openxmlformats.org/drawingml/2006/main">
             <a:pPr algn="ctr">
+              <a:buNone/>
               <a:defRPr sz="1500" b="0">
                 <a:solidFill>
                   <a:srgbClr val="60758A"/>
@@ -7342,6 +7552,7 @@
           <a:lstStyle xmlns:a="http://schemas.openxmlformats.org/drawingml/2006/main"/>
           <a:p xmlns:a="http://schemas.openxmlformats.org/drawingml/2006/main">
             <a:pPr algn="l">
+              <a:buNone/>
               <a:defRPr sz="1650" b="1">
                 <a:solidFill>
                   <a:srgbClr val="20384F"/>
@@ -7399,6 +7610,7 @@
           <a:lstStyle xmlns:a="http://schemas.openxmlformats.org/drawingml/2006/main"/>
           <a:p xmlns:a="http://schemas.openxmlformats.org/drawingml/2006/main">
             <a:pPr algn="l">
+              <a:buNone/>
               <a:defRPr sz="1350" b="0">
                 <a:solidFill>
                   <a:srgbClr val="60758A"/>
@@ -7422,6 +7634,7 @@
           </a:p>
           <a:p xmlns:a="http://schemas.openxmlformats.org/drawingml/2006/main">
             <a:pPr algn="l">
+              <a:buNone/>
               <a:defRPr sz="1350" b="0">
                 <a:solidFill>
                   <a:srgbClr val="60758A"/>
@@ -7510,6 +7723,7 @@
           <a:lstStyle xmlns:a="http://schemas.openxmlformats.org/drawingml/2006/main"/>
           <a:p xmlns:a="http://schemas.openxmlformats.org/drawingml/2006/main">
             <a:pPr algn="ctr">
+              <a:buNone/>
               <a:defRPr sz="1650" b="1">
                 <a:solidFill>
                   <a:srgbClr val="10243A"/>

</xml_diff>